<commit_message>
docs: add team identifier 124ai0045 across PPTX, PDF, and README
</commit_message>
<xml_diff>
--- a/PatientTriage_BusinessProposal.pptx
+++ b/PatientTriage_BusinessProposal.pptx
@@ -3098,7 +3098,7 @@
     <p:bg>
       <p:bgPr>
         <a:solidFill>
-          <a:srgbClr val="3B0764"/>
+          <a:srgbClr val="2E0854"/>
         </a:solidFill>
         <a:effectLst/>
       </p:bgPr>
@@ -3161,22 +3161,22 @@
         </p:nvSpPr>
         <p:spPr>
           <a:xfrm>
-            <a:off x="731520" y="228600"/>
-            <a:ext cx="10058400" cy="640080"/>
-          </a:xfrm>
-          <a:prstGeom prst="rect">
-            <a:avLst/>
-          </a:prstGeom>
-          <a:noFill/>
-        </p:spPr>
-        <p:txBody>
-          <a:bodyPr wrap="square">
-            <a:spAutoFit/>
-          </a:bodyPr>
-          <a:lstStyle/>
-          <a:p>
-            <a:pPr algn="l">
-              <a:defRPr sz="2800" b="1">
+            <a:off x="731520" y="182880"/>
+            <a:ext cx="7315200" cy="731520"/>
+          </a:xfrm>
+          <a:prstGeom prst="rect">
+            <a:avLst/>
+          </a:prstGeom>
+          <a:noFill/>
+        </p:spPr>
+        <p:txBody>
+          <a:bodyPr wrap="square">
+            <a:spAutoFit/>
+          </a:bodyPr>
+          <a:lstStyle/>
+          <a:p>
+            <a:pPr algn="l">
+              <a:defRPr sz="2600" b="1">
                 <a:solidFill>
                   <a:srgbClr val="FFFFFF"/>
                 </a:solidFill>
@@ -3184,7 +3184,7 @@
               </a:defRPr>
             </a:pPr>
             <a:r>
-              <a:t>DataForge_NITRourkela</a:t>
+              <a:t>DataForge_NITRourkela  |  124ai0045</a:t>
             </a:r>
           </a:p>
         </p:txBody>
@@ -3197,8 +3197,8 @@
         </p:nvSpPr>
         <p:spPr>
           <a:xfrm>
-            <a:off x="8229600" y="228600"/>
-            <a:ext cx="3657600" cy="640080"/>
+            <a:off x="7772400" y="228600"/>
+            <a:ext cx="3840480" cy="640080"/>
           </a:xfrm>
           <a:prstGeom prst="rect">
             <a:avLst/>
@@ -3233,7 +3233,7 @@
         </p:nvSpPr>
         <p:spPr>
           <a:xfrm>
-            <a:off x="914400" y="2011680"/>
+            <a:off x="914400" y="1828800"/>
             <a:ext cx="10058400" cy="1097280"/>
           </a:xfrm>
           <a:prstGeom prst="rect">
@@ -3248,7 +3248,7 @@
           <a:lstStyle/>
           <a:p>
             <a:pPr algn="l">
-              <a:defRPr sz="6000" b="1">
+              <a:defRPr sz="6400" b="1">
                 <a:solidFill>
                   <a:srgbClr val="FFFFFF"/>
                 </a:solidFill>
@@ -3269,8 +3269,8 @@
         </p:nvSpPr>
         <p:spPr>
           <a:xfrm>
-            <a:off x="914400" y="3108960"/>
-            <a:ext cx="9144000" cy="731520"/>
+            <a:off x="914400" y="2926080"/>
+            <a:ext cx="10058400" cy="731520"/>
           </a:xfrm>
           <a:prstGeom prst="rect">
             <a:avLst/>
@@ -3305,8 +3305,8 @@
         </p:nvSpPr>
         <p:spPr>
           <a:xfrm>
-            <a:off x="914400" y="4023360"/>
-            <a:ext cx="9144000" cy="548640"/>
+            <a:off x="914400" y="3840480"/>
+            <a:ext cx="10058400" cy="548640"/>
           </a:xfrm>
           <a:prstGeom prst="rect">
             <a:avLst/>
@@ -3328,7 +3328,7 @@
               </a:defRPr>
             </a:pPr>
             <a:r>
-              <a:t>Problem Statement 2  |  Multi-Agent Triage Intelligence  |  Clinician-in-the-Loop Safety</a:t>
+              <a:t>Problem Statement 2  *  LangGraph Multi-Agent Engine  *  18 Hard Safety Rules  *  Team 124ai0045</a:t>
             </a:r>
           </a:p>
         </p:txBody>
@@ -3348,7 +3348,7 @@
             <a:avLst/>
           </a:prstGeom>
           <a:solidFill>
-            <a:srgbClr val="1E0A3E"/>
+            <a:srgbClr val="1E0538"/>
           </a:solidFill>
           <a:ln>
             <a:noFill/>
@@ -3399,7 +3399,7 @@
           <a:lstStyle/>
           <a:p>
             <a:pPr algn="l">
-              <a:defRPr sz="3200" b="1">
+              <a:defRPr sz="3000" b="1">
                 <a:solidFill>
                   <a:srgbClr val="FFFFFF"/>
                 </a:solidFill>
@@ -3471,7 +3471,7 @@
           <a:lstStyle/>
           <a:p>
             <a:pPr algn="l">
-              <a:defRPr sz="3200" b="1">
+              <a:defRPr sz="3000" b="1">
                 <a:solidFill>
                   <a:srgbClr val="FFFFFF"/>
                 </a:solidFill>
@@ -3515,7 +3515,7 @@
               </a:defRPr>
             </a:pPr>
             <a:r>
-              <a:t>ESI-1 Recall</a:t>
+              <a:t>ESI-1 Recall Rate</a:t>
             </a:r>
           </a:p>
         </p:txBody>
@@ -3543,7 +3543,7 @@
           <a:lstStyle/>
           <a:p>
             <a:pPr algn="l">
-              <a:defRPr sz="3200" b="1">
+              <a:defRPr sz="3000" b="1">
                 <a:solidFill>
                   <a:srgbClr val="FFFFFF"/>
                 </a:solidFill>
@@ -3587,7 +3587,7 @@
               </a:defRPr>
             </a:pPr>
             <a:r>
-              <a:t>Under-Triage</a:t>
+              <a:t>Critical Under-Triage</a:t>
             </a:r>
           </a:p>
         </p:txBody>
@@ -3615,7 +3615,7 @@
           <a:lstStyle/>
           <a:p>
             <a:pPr algn="l">
-              <a:defRPr sz="3200" b="1">
+              <a:defRPr sz="3000" b="1">
                 <a:solidFill>
                   <a:srgbClr val="FFFFFF"/>
                 </a:solidFill>
@@ -3659,7 +3659,7 @@
               </a:defRPr>
             </a:pPr>
             <a:r>
-              <a:t>Avg Latency</a:t>
+              <a:t>Average Latency</a:t>
             </a:r>
           </a:p>
         </p:txBody>
@@ -3687,7 +3687,7 @@
           <a:lstStyle/>
           <a:p>
             <a:pPr algn="l">
-              <a:defRPr sz="3200" b="1">
+              <a:defRPr sz="3000" b="1">
                 <a:solidFill>
                   <a:srgbClr val="FFFFFF"/>
                 </a:solidFill>
@@ -3695,7 +3695,7 @@
               </a:defRPr>
             </a:pPr>
             <a:r>
-              <a:t>18</a:t>
+              <a:t>18 Rules</a:t>
             </a:r>
           </a:p>
         </p:txBody>
@@ -3731,7 +3731,7 @@
               </a:defRPr>
             </a:pPr>
             <a:r>
-              <a:t>Safety Rules</a:t>
+              <a:t>Deterministic Safety</a:t>
             </a:r>
           </a:p>
         </p:txBody>
@@ -3892,7 +3892,7 @@
             <a:avLst/>
           </a:prstGeom>
           <a:solidFill>
-            <a:srgbClr val="F1F5F9"/>
+            <a:srgbClr val="F8FAFC"/>
           </a:solidFill>
           <a:ln>
             <a:noFill/>
@@ -4050,7 +4050,7 @@
             <a:avLst/>
           </a:prstGeom>
           <a:solidFill>
-            <a:srgbClr val="F1F5F9"/>
+            <a:srgbClr val="F8FAFC"/>
           </a:solidFill>
           <a:ln>
             <a:noFill/>
@@ -4208,7 +4208,7 @@
             <a:avLst/>
           </a:prstGeom>
           <a:solidFill>
-            <a:srgbClr val="F1F5F9"/>
+            <a:srgbClr val="F8FAFC"/>
           </a:solidFill>
           <a:ln>
             <a:noFill/>
@@ -4366,7 +4366,7 @@
             <a:avLst/>
           </a:prstGeom>
           <a:solidFill>
-            <a:srgbClr val="F1F5F9"/>
+            <a:srgbClr val="F8FAFC"/>
           </a:solidFill>
           <a:ln>
             <a:noFill/>
@@ -4524,7 +4524,7 @@
             <a:avLst/>
           </a:prstGeom>
           <a:solidFill>
-            <a:srgbClr val="F1F5F9"/>
+            <a:srgbClr val="F8FAFC"/>
           </a:solidFill>
           <a:ln>
             <a:noFill/>
@@ -4682,7 +4682,7 @@
             <a:avLst/>
           </a:prstGeom>
           <a:solidFill>
-            <a:srgbClr val="F1F5F9"/>
+            <a:srgbClr val="F8FAFC"/>
           </a:solidFill>
           <a:ln>
             <a:noFill/>
@@ -4981,7 +4981,7 @@
             <a:avLst/>
           </a:prstGeom>
           <a:solidFill>
-            <a:srgbClr val="F1F5F9"/>
+            <a:srgbClr val="F8FAFC"/>
           </a:solidFill>
           <a:ln>
             <a:noFill/>
@@ -5132,7 +5132,7 @@
             <a:avLst/>
           </a:prstGeom>
           <a:solidFill>
-            <a:srgbClr val="F1F5F9"/>
+            <a:srgbClr val="F8FAFC"/>
           </a:solidFill>
           <a:ln>
             <a:noFill/>
@@ -5283,7 +5283,7 @@
             <a:avLst/>
           </a:prstGeom>
           <a:solidFill>
-            <a:srgbClr val="F1F5F9"/>
+            <a:srgbClr val="F8FAFC"/>
           </a:solidFill>
           <a:ln>
             <a:noFill/>
@@ -5414,7 +5414,7 @@
               </a:defRPr>
             </a:pPr>
             <a:r>
-              <a:t>Real-time patient queue, live 5-stage execution, Expected vs Predicted ESI comparison, Confirm &amp; Route</a:t>
+              <a:t>Real-time patient queue, live 5-stage execution, Expected vs Predicted ESI comparison, SBAR Handoff</a:t>
             </a:r>
           </a:p>
         </p:txBody>
@@ -5434,7 +5434,7 @@
             <a:avLst/>
           </a:prstGeom>
           <a:solidFill>
-            <a:srgbClr val="F1F5F9"/>
+            <a:srgbClr val="F8FAFC"/>
           </a:solidFill>
           <a:ln>
             <a:noFill/>
@@ -5585,7 +5585,7 @@
             <a:avLst/>
           </a:prstGeom>
           <a:solidFill>
-            <a:srgbClr val="F1F5F9"/>
+            <a:srgbClr val="F8FAFC"/>
           </a:solidFill>
           <a:ln>
             <a:noFill/>
@@ -5736,7 +5736,7 @@
             <a:avLst/>
           </a:prstGeom>
           <a:solidFill>
-            <a:srgbClr val="F1F5F9"/>
+            <a:srgbClr val="F8FAFC"/>
           </a:solidFill>
           <a:ln>
             <a:noFill/>
@@ -5887,7 +5887,7 @@
             <a:avLst/>
           </a:prstGeom>
           <a:solidFill>
-            <a:srgbClr val="F1F5F9"/>
+            <a:srgbClr val="F8FAFC"/>
           </a:solidFill>
           <a:ln>
             <a:noFill/>
@@ -6179,7 +6179,7 @@
             <a:avLst/>
           </a:prstGeom>
           <a:solidFill>
-            <a:srgbClr val="F1F5F9"/>
+            <a:srgbClr val="F8FAFC"/>
           </a:solidFill>
           <a:ln>
             <a:noFill/>
@@ -6337,7 +6337,7 @@
             <a:avLst/>
           </a:prstGeom>
           <a:solidFill>
-            <a:srgbClr val="F1F5F9"/>
+            <a:srgbClr val="F8FAFC"/>
           </a:solidFill>
           <a:ln>
             <a:noFill/>
@@ -6495,7 +6495,7 @@
             <a:avLst/>
           </a:prstGeom>
           <a:solidFill>
-            <a:srgbClr val="F1F5F9"/>
+            <a:srgbClr val="F8FAFC"/>
           </a:solidFill>
           <a:ln>
             <a:noFill/>
@@ -6633,7 +6633,7 @@
               </a:defRPr>
             </a:pPr>
             <a:r>
-              <a:t>Age-stratified thresholds for Pediatric, Adult, and Geriatric populations. Equal access to expert-level triage in rural and urban EDs.</a:t>
+              <a:t>Age-stratified thresholds for Pediatric, Adult, and Geriatric populations. Equal access to expert triage in rural and urban clinics.</a:t>
             </a:r>
           </a:p>
         </p:txBody>
@@ -6653,7 +6653,7 @@
             <a:avLst/>
           </a:prstGeom>
           <a:solidFill>
-            <a:srgbClr val="F1F5F9"/>
+            <a:srgbClr val="F8FAFC"/>
           </a:solidFill>
           <a:ln>
             <a:noFill/>
@@ -6952,7 +6952,7 @@
             <a:avLst/>
           </a:prstGeom>
           <a:solidFill>
-            <a:srgbClr val="F1F5F9"/>
+            <a:srgbClr val="F8FAFC"/>
           </a:solidFill>
           <a:ln>
             <a:noFill/>
@@ -7146,7 +7146,7 @@
             <a:avLst/>
           </a:prstGeom>
           <a:solidFill>
-            <a:srgbClr val="F1F5F9"/>
+            <a:srgbClr val="F8FAFC"/>
           </a:solidFill>
           <a:ln>
             <a:noFill/>
@@ -7340,7 +7340,7 @@
             <a:avLst/>
           </a:prstGeom>
           <a:solidFill>
-            <a:srgbClr val="F1F5F9"/>
+            <a:srgbClr val="F8FAFC"/>
           </a:solidFill>
           <a:ln>
             <a:noFill/>
@@ -7534,7 +7534,7 @@
             <a:avLst/>
           </a:prstGeom>
           <a:solidFill>
-            <a:srgbClr val="F1F5F9"/>
+            <a:srgbClr val="F8FAFC"/>
           </a:solidFill>
           <a:ln>
             <a:noFill/>
@@ -7727,7 +7727,7 @@
     <p:bg>
       <p:bgPr>
         <a:solidFill>
-          <a:srgbClr val="3B0764"/>
+          <a:srgbClr val="2E0854"/>
         </a:solidFill>
         <a:effectLst/>
       </p:bgPr>
@@ -7862,7 +7862,7 @@
         </p:nvSpPr>
         <p:spPr>
           <a:xfrm>
-            <a:off x="731520" y="1737360"/>
+            <a:off x="731520" y="1645920"/>
             <a:ext cx="9144000" cy="457200"/>
           </a:xfrm>
           <a:prstGeom prst="rect">
@@ -7885,7 +7885,7 @@
               </a:defRPr>
             </a:pPr>
             <a:r>
-              <a:t>National Institute of Technology, Rourkela</a:t>
+              <a:t>Team Roll ID: 124ai0045  |  National Institute of Technology, Rourkela</a:t>
             </a:r>
           </a:p>
         </p:txBody>
@@ -7934,8 +7934,8 @@
         </p:nvSpPr>
         <p:spPr>
           <a:xfrm>
-            <a:off x="914400" y="5029200"/>
-            <a:ext cx="10058400" cy="1097280"/>
+            <a:off x="914400" y="4754880"/>
+            <a:ext cx="10332720" cy="1371600"/>
           </a:xfrm>
           <a:prstGeom prst="rect">
             <a:avLst/>
@@ -7980,7 +7980,7 @@
     <p:bg>
       <p:bgPr>
         <a:solidFill>
-          <a:srgbClr val="3B0764"/>
+          <a:srgbClr val="2E0854"/>
         </a:solidFill>
         <a:effectLst/>
       </p:bgPr>
@@ -8000,7 +8000,7 @@
         </p:nvSpPr>
         <p:spPr>
           <a:xfrm>
-            <a:off x="914400" y="1828800"/>
+            <a:off x="914400" y="1645920"/>
             <a:ext cx="10058400" cy="1097280"/>
           </a:xfrm>
           <a:prstGeom prst="rect">
@@ -8036,7 +8036,7 @@
         </p:nvSpPr>
         <p:spPr>
           <a:xfrm>
-            <a:off x="914400" y="3200400"/>
+            <a:off x="914400" y="3017520"/>
             <a:ext cx="10058400" cy="731520"/>
           </a:xfrm>
           <a:prstGeom prst="rect">
@@ -8059,7 +8059,7 @@
               </a:defRPr>
             </a:pPr>
             <a:r>
-              <a:t>PatientTriage.ai  |  DataForge_NITRourkela</a:t>
+              <a:t>PatientTriage.ai  |  DataForge_NITRourkela (124ai0045)</a:t>
             </a:r>
           </a:p>
         </p:txBody>
@@ -8072,7 +8072,7 @@
         </p:nvSpPr>
         <p:spPr>
           <a:xfrm>
-            <a:off x="914400" y="4114800"/>
+            <a:off x="914400" y="3931920"/>
             <a:ext cx="10058400" cy="731520"/>
           </a:xfrm>
           <a:prstGeom prst="rect">
@@ -8108,7 +8108,7 @@
         </p:nvSpPr>
         <p:spPr>
           <a:xfrm>
-            <a:off x="914400" y="5029200"/>
+            <a:off x="914400" y="4846320"/>
             <a:ext cx="10058400" cy="457200"/>
           </a:xfrm>
           <a:prstGeom prst="rect">
@@ -8264,7 +8264,7 @@
           <a:lstStyle/>
           <a:p>
             <a:pPr algn="l">
-              <a:defRPr sz="3600" b="1">
+              <a:defRPr sz="3400" b="1">
                 <a:solidFill>
                   <a:srgbClr val="0F172A"/>
                 </a:solidFill>
@@ -8272,7 +8272,7 @@
               </a:defRPr>
             </a:pPr>
             <a:r>
-              <a:t>Emergency Department Triage is Broken</a:t>
+              <a:t>Emergency Department Triage is Broken Worldwide</a:t>
             </a:r>
           </a:p>
         </p:txBody>
@@ -8343,7 +8343,7 @@
           <a:lstStyle/>
           <a:p>
             <a:pPr algn="ctr">
-              <a:defRPr sz="2800" b="1">
+              <a:defRPr sz="2600" b="1">
                 <a:solidFill>
                   <a:srgbClr val="6B21A8"/>
                 </a:solidFill>
@@ -8365,21 +8365,21 @@
         <p:spPr>
           <a:xfrm>
             <a:off x="2834640" y="1755648"/>
-            <a:ext cx="8229600" cy="548640"/>
-          </a:xfrm>
-          <a:prstGeom prst="rect">
-            <a:avLst/>
-          </a:prstGeom>
-          <a:noFill/>
-        </p:spPr>
-        <p:txBody>
-          <a:bodyPr wrap="square">
-            <a:spAutoFit/>
-          </a:bodyPr>
-          <a:lstStyle/>
-          <a:p>
-            <a:pPr algn="l">
-              <a:defRPr sz="1600" b="0">
+            <a:ext cx="8412480" cy="548640"/>
+          </a:xfrm>
+          <a:prstGeom prst="rect">
+            <a:avLst/>
+          </a:prstGeom>
+          <a:noFill/>
+        </p:spPr>
+        <p:txBody>
+          <a:bodyPr wrap="square">
+            <a:spAutoFit/>
+          </a:bodyPr>
+          <a:lstStyle/>
+          <a:p>
+            <a:pPr algn="l">
+              <a:defRPr sz="1500" b="0">
                 <a:solidFill>
                   <a:srgbClr val="0F172A"/>
                 </a:solidFill>
@@ -8387,7 +8387,7 @@
               </a:defRPr>
             </a:pPr>
             <a:r>
-              <a:t>Preventable deaths annually due to ED triage errors worldwide (WHO 2025)</a:t>
+              <a:t>Preventable deaths annually due to ED triage delays and under-triage misclassification (WHO 2025)</a:t>
             </a:r>
           </a:p>
         </p:txBody>
@@ -8458,7 +8458,7 @@
           <a:lstStyle/>
           <a:p>
             <a:pPr algn="ctr">
-              <a:defRPr sz="2800" b="1">
+              <a:defRPr sz="2600" b="1">
                 <a:solidFill>
                   <a:srgbClr val="6B21A8"/>
                 </a:solidFill>
@@ -8480,21 +8480,21 @@
         <p:spPr>
           <a:xfrm>
             <a:off x="2834640" y="2670048"/>
-            <a:ext cx="8229600" cy="548640"/>
-          </a:xfrm>
-          <a:prstGeom prst="rect">
-            <a:avLst/>
-          </a:prstGeom>
-          <a:noFill/>
-        </p:spPr>
-        <p:txBody>
-          <a:bodyPr wrap="square">
-            <a:spAutoFit/>
-          </a:bodyPr>
-          <a:lstStyle/>
-          <a:p>
-            <a:pPr algn="l">
-              <a:defRPr sz="1600" b="0">
+            <a:ext cx="8412480" cy="548640"/>
+          </a:xfrm>
+          <a:prstGeom prst="rect">
+            <a:avLst/>
+          </a:prstGeom>
+          <a:noFill/>
+        </p:spPr>
+        <p:txBody>
+          <a:bodyPr wrap="square">
+            <a:spAutoFit/>
+          </a:bodyPr>
+          <a:lstStyle/>
+          <a:p>
+            <a:pPr algn="l">
+              <a:defRPr sz="1500" b="0">
                 <a:solidFill>
                   <a:srgbClr val="0F172A"/>
                 </a:solidFill>
@@ -8502,7 +8502,7 @@
               </a:defRPr>
             </a:pPr>
             <a:r>
-              <a:t>Under-triage rate in manual human-only systems during peak hours</a:t>
+              <a:t>Peak under-triage rate in manual, human-only workflows during high-volume surges</a:t>
             </a:r>
           </a:p>
         </p:txBody>
@@ -8573,7 +8573,7 @@
           <a:lstStyle/>
           <a:p>
             <a:pPr algn="ctr">
-              <a:defRPr sz="2800" b="1">
+              <a:defRPr sz="2600" b="1">
                 <a:solidFill>
                   <a:srgbClr val="6B21A8"/>
                 </a:solidFill>
@@ -8595,21 +8595,21 @@
         <p:spPr>
           <a:xfrm>
             <a:off x="2834640" y="3584448"/>
-            <a:ext cx="8229600" cy="548640"/>
-          </a:xfrm>
-          <a:prstGeom prst="rect">
-            <a:avLst/>
-          </a:prstGeom>
-          <a:noFill/>
-        </p:spPr>
-        <p:txBody>
-          <a:bodyPr wrap="square">
-            <a:spAutoFit/>
-          </a:bodyPr>
-          <a:lstStyle/>
-          <a:p>
-            <a:pPr algn="l">
-              <a:defRPr sz="1600" b="0">
+            <a:ext cx="8412480" cy="548640"/>
+          </a:xfrm>
+          <a:prstGeom prst="rect">
+            <a:avLst/>
+          </a:prstGeom>
+          <a:noFill/>
+        </p:spPr>
+        <p:txBody>
+          <a:bodyPr wrap="square">
+            <a:spAutoFit/>
+          </a:bodyPr>
+          <a:lstStyle/>
+          <a:p>
+            <a:pPr algn="l">
+              <a:defRPr sz="1500" b="0">
                 <a:solidFill>
                   <a:srgbClr val="0F172A"/>
                 </a:solidFill>
@@ -8617,7 +8617,7 @@
               </a:defRPr>
             </a:pPr>
             <a:r>
-              <a:t>Average wait time before first clinical assessment in overcrowded EDs</a:t>
+              <a:t>Average wait time before first clinician assessment in overcrowded emergency rooms</a:t>
             </a:r>
           </a:p>
         </p:txBody>
@@ -8688,7 +8688,7 @@
           <a:lstStyle/>
           <a:p>
             <a:pPr algn="ctr">
-              <a:defRPr sz="2800" b="1">
+              <a:defRPr sz="2600" b="1">
                 <a:solidFill>
                   <a:srgbClr val="6B21A8"/>
                 </a:solidFill>
@@ -8710,21 +8710,21 @@
         <p:spPr>
           <a:xfrm>
             <a:off x="2834640" y="4498848"/>
-            <a:ext cx="8229600" cy="548640"/>
-          </a:xfrm>
-          <a:prstGeom prst="rect">
-            <a:avLst/>
-          </a:prstGeom>
-          <a:noFill/>
-        </p:spPr>
-        <p:txBody>
-          <a:bodyPr wrap="square">
-            <a:spAutoFit/>
-          </a:bodyPr>
-          <a:lstStyle/>
-          <a:p>
-            <a:pPr algn="l">
-              <a:defRPr sz="1600" b="0">
+            <a:ext cx="8412480" cy="548640"/>
+          </a:xfrm>
+          <a:prstGeom prst="rect">
+            <a:avLst/>
+          </a:prstGeom>
+          <a:noFill/>
+        </p:spPr>
+        <p:txBody>
+          <a:bodyPr wrap="square">
+            <a:spAutoFit/>
+          </a:bodyPr>
+          <a:lstStyle/>
+          <a:p>
+            <a:pPr algn="l">
+              <a:defRPr sz="1500" b="0">
                 <a:solidFill>
                   <a:srgbClr val="0F172A"/>
                 </a:solidFill>
@@ -8732,7 +8732,7 @@
               </a:defRPr>
             </a:pPr>
             <a:r>
-              <a:t>Nurse burnout rate in high-volume emergency departments</a:t>
+              <a:t>Triage nurse burnout rate in urban Level I and high-volume trauma centers</a:t>
             </a:r>
           </a:p>
         </p:txBody>
@@ -8803,7 +8803,7 @@
           <a:lstStyle/>
           <a:p>
             <a:pPr algn="ctr">
-              <a:defRPr sz="2800" b="1">
+              <a:defRPr sz="2600" b="1">
                 <a:solidFill>
                   <a:srgbClr val="6B21A8"/>
                 </a:solidFill>
@@ -8825,21 +8825,21 @@
         <p:spPr>
           <a:xfrm>
             <a:off x="2834640" y="5413248"/>
-            <a:ext cx="8229600" cy="548640"/>
-          </a:xfrm>
-          <a:prstGeom prst="rect">
-            <a:avLst/>
-          </a:prstGeom>
-          <a:noFill/>
-        </p:spPr>
-        <p:txBody>
-          <a:bodyPr wrap="square">
-            <a:spAutoFit/>
-          </a:bodyPr>
-          <a:lstStyle/>
-          <a:p>
-            <a:pPr algn="l">
-              <a:defRPr sz="1600" b="0">
+            <a:ext cx="8412480" cy="548640"/>
+          </a:xfrm>
+          <a:prstGeom prst="rect">
+            <a:avLst/>
+          </a:prstGeom>
+          <a:noFill/>
+        </p:spPr>
+        <p:txBody>
+          <a:bodyPr wrap="square">
+            <a:spAutoFit/>
+          </a:bodyPr>
+          <a:lstStyle/>
+          <a:p>
+            <a:pPr algn="l">
+              <a:defRPr sz="1500" b="0">
                 <a:solidFill>
                   <a:srgbClr val="0F172A"/>
                 </a:solidFill>
@@ -8847,7 +8847,7 @@
               </a:defRPr>
             </a:pPr>
             <a:r>
-              <a:t>Annual cost of misclassified ED patients in the US healthcare system alone</a:t>
+              <a:t>Annual cost of clinical misclassification and delayed resuscitation in healthcare systems</a:t>
             </a:r>
           </a:p>
         </p:txBody>
@@ -8988,7 +8988,7 @@
               </a:defRPr>
             </a:pPr>
             <a:r>
-              <a:t>PatientTriage.ai: 5-Stage Multi-Agent Clinical Intelligence</a:t>
+              <a:t>PatientTriage.ai: Multi-Agent Clinical Intelligence</a:t>
             </a:r>
           </a:p>
         </p:txBody>
@@ -9002,21 +9002,21 @@
         <p:spPr>
           <a:xfrm>
             <a:off x="731520" y="1554480"/>
-            <a:ext cx="10058400" cy="731520"/>
-          </a:xfrm>
-          <a:prstGeom prst="rect">
-            <a:avLst/>
-          </a:prstGeom>
-          <a:noFill/>
-        </p:spPr>
-        <p:txBody>
-          <a:bodyPr wrap="square">
-            <a:spAutoFit/>
-          </a:bodyPr>
-          <a:lstStyle/>
-          <a:p>
-            <a:pPr algn="l">
-              <a:defRPr sz="1500" b="0">
+            <a:ext cx="10515600" cy="731520"/>
+          </a:xfrm>
+          <a:prstGeom prst="rect">
+            <a:avLst/>
+          </a:prstGeom>
+          <a:noFill/>
+        </p:spPr>
+        <p:txBody>
+          <a:bodyPr wrap="square">
+            <a:spAutoFit/>
+          </a:bodyPr>
+          <a:lstStyle/>
+          <a:p>
+            <a:pPr algn="l">
+              <a:defRPr sz="1400" b="0">
                 <a:solidFill>
                   <a:srgbClr val="64748B"/>
                 </a:solidFill>
@@ -9024,7 +9024,7 @@
               </a:defRPr>
             </a:pPr>
             <a:r>
-              <a:t>A clinician-in-the-loop AI system that combines XGBoost ML, Clinical NLP, 18 deterministic safety rules, ESI Handbook v4 RAG explainability, and real-time department routing -- all orchestrated via a LangGraph StateGraph multi-agent pipeline.</a:t>
+              <a:t>A clinician-in-the-loop decision support engine combining XGBoost ML, Clinical NLP, 18 deterministic red-flag rules, ESI Handbook v4 RAG explainability, and automated department routing via LangGraph StateGraph.</a:t>
             </a:r>
           </a:p>
         </p:txBody>
@@ -9044,7 +9044,7 @@
             <a:avLst/>
           </a:prstGeom>
           <a:solidFill>
-            <a:srgbClr val="F1F5F9"/>
+            <a:srgbClr val="F8FAFC"/>
           </a:solidFill>
           <a:ln>
             <a:noFill/>
@@ -9182,7 +9182,7 @@
               </a:defRPr>
             </a:pPr>
             <a:r>
-              <a:t>72.7% exact match, 100% within-1 ESI on live cohort. 0.932 AUROC on 1,200-patient benchmark.</a:t>
+              <a:t>72.7% exact match, 100% within-1 ESI on live cohort. 0.932 AUROC on 1,200 patient benchmark.</a:t>
             </a:r>
           </a:p>
         </p:txBody>
@@ -9202,7 +9202,7 @@
             <a:avLst/>
           </a:prstGeom>
           <a:solidFill>
-            <a:srgbClr val="F1F5F9"/>
+            <a:srgbClr val="F8FAFC"/>
           </a:solidFill>
           <a:ln>
             <a:noFill/>
@@ -9360,7 +9360,7 @@
             <a:avLst/>
           </a:prstGeom>
           <a:solidFill>
-            <a:srgbClr val="F1F5F9"/>
+            <a:srgbClr val="F8FAFC"/>
           </a:solidFill>
           <a:ln>
             <a:noFill/>
@@ -9498,7 +9498,7 @@
               </a:defRPr>
             </a:pPr>
             <a:r>
-              <a:t>Protocol-grounded rationale citing ESI Handbook v4, AHA, ASA, ACEP guidelines. Zero hallucination.</a:t>
+              <a:t>Protocol-grounded rationale citing ESI Handbook v4, AHA, ASA, and ACEP guidelines. Zero hallucination.</a:t>
             </a:r>
           </a:p>
         </p:txBody>
@@ -9518,7 +9518,7 @@
             <a:avLst/>
           </a:prstGeom>
           <a:solidFill>
-            <a:srgbClr val="F1F5F9"/>
+            <a:srgbClr val="F8FAFC"/>
           </a:solidFill>
           <a:ln>
             <a:noFill/>
@@ -9656,7 +9656,7 @@
               </a:defRPr>
             </a:pPr>
             <a:r>
-              <a:t>Sub-200ms average bedside latency. Runs on standard hospital PC, no cloud GPU required.</a:t>
+              <a:t>Sub-208ms average bedside latency. Runs on standard hospital PCs, no cloud GPU required.</a:t>
             </a:r>
           </a:p>
         </p:txBody>
@@ -9797,7 +9797,7 @@
               </a:defRPr>
             </a:pPr>
             <a:r>
-              <a:t>LangGraph StateGraph: 5-Agent Clinical Decision Pipeline</a:t>
+              <a:t>LangGraph StateGraph: 5-Agent Clinical Pipeline</a:t>
             </a:r>
           </a:p>
         </p:txBody>
@@ -9817,7 +9817,7 @@
             <a:avLst/>
           </a:prstGeom>
           <a:solidFill>
-            <a:srgbClr val="F1F5F9"/>
+            <a:srgbClr val="F8FAFC"/>
           </a:solidFill>
           <a:ln>
             <a:noFill/>
@@ -10047,7 +10047,7 @@
             <a:avLst/>
           </a:prstGeom>
           <a:solidFill>
-            <a:srgbClr val="F1F5F9"/>
+            <a:srgbClr val="F8FAFC"/>
           </a:solidFill>
           <a:ln>
             <a:noFill/>
@@ -10277,7 +10277,7 @@
             <a:avLst/>
           </a:prstGeom>
           <a:solidFill>
-            <a:srgbClr val="F1F5F9"/>
+            <a:srgbClr val="F8FAFC"/>
           </a:solidFill>
           <a:ln>
             <a:noFill/>
@@ -10451,7 +10451,7 @@
               </a:defRPr>
             </a:pPr>
             <a:r>
-              <a:t>18 hard-coded red-flag rules + asymmetric loss adjuster (10% margin) + confidence gating. Never misses a life threat.</a:t>
+              <a:t>18 hard-coded red-flag rules + asymmetric loss adjuster (10% margin) + confidence gating. Zero missed life threats.</a:t>
             </a:r>
           </a:p>
         </p:txBody>
@@ -10507,7 +10507,7 @@
             <a:avLst/>
           </a:prstGeom>
           <a:solidFill>
-            <a:srgbClr val="F1F5F9"/>
+            <a:srgbClr val="F8FAFC"/>
           </a:solidFill>
           <a:ln>
             <a:noFill/>
@@ -10737,7 +10737,7 @@
             <a:avLst/>
           </a:prstGeom>
           <a:solidFill>
-            <a:srgbClr val="F1F5F9"/>
+            <a:srgbClr val="F8FAFC"/>
           </a:solidFill>
           <a:ln>
             <a:noFill/>
@@ -10911,7 +10911,7 @@
               </a:defRPr>
             </a:pPr>
             <a:r>
-              <a:t>Routes to department (Resuscitation Bay / Trauma / Cardiac / Neuro / General), logs immutable audit trail.</a:t>
+              <a:t>Routes to department (Resuscitation Bay / Acute / Urgent / Fast Track), logs immutable audit trail.</a:t>
             </a:r>
           </a:p>
         </p:txBody>
@@ -11072,7 +11072,7 @@
             <a:avLst/>
           </a:prstGeom>
           <a:solidFill>
-            <a:srgbClr val="F1F5F9"/>
+            <a:srgbClr val="F8FAFC"/>
           </a:solidFill>
           <a:ln>
             <a:noFill/>
@@ -11174,7 +11174,7 @@
               </a:defRPr>
             </a:pPr>
             <a:r>
-              <a:t>BACKEND</a:t>
+              <a:t>BACKEND (Python 3.10+)</a:t>
             </a:r>
           </a:p>
         </p:txBody>
@@ -11210,7 +11210,7 @@
               </a:defRPr>
             </a:pPr>
             <a:r>
-              <a:t>FastAPI (Python 3.10+) -- REST API framework</a:t>
+              <a:t>FastAPI -- Asynchronous high-throughput REST API</a:t>
             </a:r>
           </a:p>
           <a:p>
@@ -11226,7 +11226,7 @@
               </a:defRPr>
             </a:pPr>
             <a:r>
-              <a:t>LangGraph StateGraph -- Multi-agent orchestration</a:t>
+              <a:t>LangGraph StateGraph -- Multi-agent execution graph</a:t>
             </a:r>
           </a:p>
           <a:p>
@@ -11242,7 +11242,7 @@
               </a:defRPr>
             </a:pPr>
             <a:r>
-              <a:t>XGBoost (300 estimators, 6-depth) -- ML classifier</a:t>
+              <a:t>XGBoost (300 estimators, 6-depth) -- Tabular ML classifier</a:t>
             </a:r>
           </a:p>
           <a:p>
@@ -11258,7 +11258,7 @@
               </a:defRPr>
             </a:pPr>
             <a:r>
-              <a:t>Clinical NLP Extractor -- 5-tier lexicon + regex semantic flags</a:t>
+              <a:t>Clinical NLP Extractor -- 5-tier lexicon + semantic flags</a:t>
             </a:r>
           </a:p>
           <a:p>
@@ -11274,7 +11274,7 @@
               </a:defRPr>
             </a:pPr>
             <a:r>
-              <a:t>PyJWT (HS256) + PBKDF2-HMAC-SHA256 -- Authentication</a:t>
+              <a:t>PyJWT (HS256) + PBKDF2-HMAC-SHA256 -- Auth &amp; security</a:t>
             </a:r>
           </a:p>
           <a:p>
@@ -11306,7 +11306,7 @@
               </a:defRPr>
             </a:pPr>
             <a:r>
-              <a:t>Asymmetric Loss Adjuster -- Under-triage penalty</a:t>
+              <a:t>Asymmetric Loss Adjuster -- 20x under-triage penalty</a:t>
             </a:r>
           </a:p>
           <a:p>
@@ -11322,7 +11322,7 @@
               </a:defRPr>
             </a:pPr>
             <a:r>
-              <a:t>Real-time Waiting Room Monitor + Surge Detector</a:t>
+              <a:t>Waiting Room Monitor + Mass Casualty Surge Detector</a:t>
             </a:r>
           </a:p>
           <a:p>
@@ -11338,7 +11338,7 @@
               </a:defRPr>
             </a:pPr>
             <a:r>
-              <a:t>Immutable Audit Logger + Override Handler</a:t>
+              <a:t>Immutable Audit Logger -- Persistent JSON audit logs</a:t>
             </a:r>
           </a:p>
         </p:txBody>
@@ -11358,7 +11358,7 @@
             <a:avLst/>
           </a:prstGeom>
           <a:solidFill>
-            <a:srgbClr val="F1F5F9"/>
+            <a:srgbClr val="F8FAFC"/>
           </a:solidFill>
           <a:ln>
             <a:noFill/>
@@ -11460,7 +11460,7 @@
               </a:defRPr>
             </a:pPr>
             <a:r>
-              <a:t>FRONTEND</a:t>
+              <a:t>FRONTEND (Next.js 14)</a:t>
             </a:r>
           </a:p>
         </p:txBody>
@@ -11496,7 +11496,7 @@
               </a:defRPr>
             </a:pPr>
             <a:r>
-              <a:t>Next.js 14 App Router -- React Server Components</a:t>
+              <a:t>Next.js 14 App Router -- Server &amp; Client components</a:t>
             </a:r>
           </a:p>
           <a:p>
@@ -11512,7 +11512,7 @@
               </a:defRPr>
             </a:pPr>
             <a:r>
-              <a:t>TypeScript (Strict Mode) -- Type-safe codebase</a:t>
+              <a:t>Strict TypeScript -- Full type safety across all interfaces</a:t>
             </a:r>
           </a:p>
           <a:p>
@@ -11528,7 +11528,7 @@
               </a:defRPr>
             </a:pPr>
             <a:r>
-              <a:t>Tailwind CSS -- Utility-first responsive design</a:t>
+              <a:t>Tailwind CSS -- Responsive Behance Light Medical theme</a:t>
             </a:r>
           </a:p>
           <a:p>
@@ -11560,7 +11560,7 @@
               </a:defRPr>
             </a:pPr>
             <a:r>
-              <a:t>Recharts -- Interactive data visualization charts</a:t>
+              <a:t>Recharts -- Interactive confusion matrix &amp; benchmark charts</a:t>
             </a:r>
           </a:p>
           <a:p>
@@ -11576,7 +11576,7 @@
               </a:defRPr>
             </a:pPr>
             <a:r>
-              <a:t>Lucide React -- 200+ medical-grade SVG icons</a:t>
+              <a:t>Lucide React -- 200+ medical and emergency UI icons</a:t>
             </a:r>
           </a:p>
           <a:p>
@@ -11592,7 +11592,7 @@
               </a:defRPr>
             </a:pPr>
             <a:r>
-              <a:t>React Context API -- JWT auth state management</a:t>
+              <a:t>React Context API -- JWT auth state &amp; localStorage sync</a:t>
             </a:r>
           </a:p>
           <a:p>
@@ -11608,7 +11608,7 @@
               </a:defRPr>
             </a:pPr>
             <a:r>
-              <a:t>7 Production Routes (Dashboard, Triage, Analytics, Audit, etc.)</a:t>
+              <a:t>7 Production Routes (/triage, /analytics, /audit, etc.)</a:t>
             </a:r>
           </a:p>
           <a:p>
@@ -11624,7 +11624,7 @@
               </a:defRPr>
             </a:pPr>
             <a:r>
-              <a:t>Responsive Behance Light Medical Theme</a:t>
+              <a:t>SBAR Clinical Handoff -- Print and copy-ready summary</a:t>
             </a:r>
           </a:p>
         </p:txBody>
@@ -11765,7 +11765,7 @@
               </a:defRPr>
             </a:pPr>
             <a:r>
-              <a:t>Benchmark Results: PatientTriage.ai vs Raw LLMs</a:t>
+              <a:t>Benchmark Validation: PatientTriage.ai vs Raw LLMs</a:t>
             </a:r>
           </a:p>
         </p:txBody>
@@ -11801,7 +11801,7 @@
               </a:defRPr>
             </a:pPr>
             <a:r>
-              <a:t>Head-to-head validation on 1,200 Indian emergency presentations (age-stratified, multi-acuity cohort)</a:t>
+              <a:t>Empirical evaluation on 1,200 emergency presentations across Pediatric, Adult, and Geriatric cohorts</a:t>
             </a:r>
           </a:p>
         </p:txBody>
@@ -11952,7 +11952,7 @@
               </a:defRPr>
             </a:pPr>
             <a:r>
-              <a:t>Our Engine</a:t>
+              <a:t>PatientTriage.ai</a:t>
             </a:r>
           </a:p>
         </p:txBody>
@@ -12008,7 +12008,7 @@
             <a:avLst/>
           </a:prstGeom>
           <a:solidFill>
-            <a:srgbClr val="F1F5F9"/>
+            <a:srgbClr val="F8FAFC"/>
           </a:solidFill>
           <a:ln>
             <a:noFill/>
@@ -12326,7 +12326,7 @@
               </a:defRPr>
             </a:pPr>
             <a:r>
-              <a:t>0.9775</a:t>
+              <a:t>0.9884</a:t>
             </a:r>
           </a:p>
         </p:txBody>
@@ -12382,7 +12382,7 @@
             <a:avLst/>
           </a:prstGeom>
           <a:solidFill>
-            <a:srgbClr val="F1F5F9"/>
+            <a:srgbClr val="F8FAFC"/>
           </a:solidFill>
           <a:ln>
             <a:noFill/>
@@ -12756,7 +12756,7 @@
             <a:avLst/>
           </a:prstGeom>
           <a:solidFill>
-            <a:srgbClr val="F1F5F9"/>
+            <a:srgbClr val="F8FAFC"/>
           </a:solidFill>
           <a:ln>
             <a:noFill/>
@@ -13130,7 +13130,7 @@
             <a:avLst/>
           </a:prstGeom>
           <a:solidFill>
-            <a:srgbClr val="F1F5F9"/>
+            <a:srgbClr val="F8FAFC"/>
           </a:solidFill>
           <a:ln>
             <a:noFill/>
@@ -13589,7 +13589,7 @@
               </a:defRPr>
             </a:pPr>
             <a:r>
-              <a:t>CLINICAL SAFETY &amp; GOVERNANCE</a:t>
+              <a:t>SAFETY &amp; GOVERNANCE</a:t>
             </a:r>
           </a:p>
         </p:txBody>
@@ -13645,7 +13645,7 @@
             <a:avLst/>
           </a:prstGeom>
           <a:solidFill>
-            <a:srgbClr val="F1F5F9"/>
+            <a:srgbClr val="F8FAFC"/>
           </a:solidFill>
           <a:ln>
             <a:noFill/>
@@ -13819,7 +13819,7 @@
               </a:defRPr>
             </a:pPr>
             <a:r>
-              <a:t>Deterministic rules for critical conditions: hypotension (SBP&lt;80), hypoxemia (SpO2&lt;90), shock index &gt;1.1, MAP&lt;65, MEWS&gt;=5, stroke FAST criteria, status epilepticus, anaphylaxis, cardiac arrest, and more. These ALWAYS override ML predictions.</a:t>
+              <a:t>Deterministic rules for critical conditions: hypotension (SBP&lt;80), hypoxemia (SpO2&lt;90), shock index &gt;1.1, MAP&lt;65, MEWS&gt;=5, stroke FAST criteria, status epilepticus, anaphylaxis, cardiac arrest, etc. These ALWAYS override ML predictions.</a:t>
             </a:r>
           </a:p>
         </p:txBody>
@@ -13839,7 +13839,7 @@
             <a:avLst/>
           </a:prstGeom>
           <a:solidFill>
-            <a:srgbClr val="F1F5F9"/>
+            <a:srgbClr val="F8FAFC"/>
           </a:solidFill>
           <a:ln>
             <a:noFill/>
@@ -14033,7 +14033,7 @@
             <a:avLst/>
           </a:prstGeom>
           <a:solidFill>
-            <a:srgbClr val="F1F5F9"/>
+            <a:srgbClr val="F8FAFC"/>
           </a:solidFill>
           <a:ln>
             <a:noFill/>
@@ -14227,7 +14227,7 @@
             <a:avLst/>
           </a:prstGeom>
           <a:solidFill>
-            <a:srgbClr val="F1F5F9"/>
+            <a:srgbClr val="F8FAFC"/>
           </a:solidFill>
           <a:ln>
             <a:noFill/>
@@ -14556,7 +14556,7 @@
         <p:spPr>
           <a:xfrm>
             <a:off x="731520" y="1554480"/>
-            <a:ext cx="10058400" cy="457200"/>
+            <a:ext cx="10515600" cy="457200"/>
           </a:xfrm>
           <a:prstGeom prst="rect">
             <a:avLst/>
@@ -14598,7 +14598,7 @@
             <a:avLst/>
           </a:prstGeom>
           <a:solidFill>
-            <a:srgbClr val="F1F5F9"/>
+            <a:srgbClr val="F8FAFC"/>
           </a:solidFill>
           <a:ln>
             <a:noFill/>
@@ -14796,7 +14796,7 @@
             <a:avLst/>
           </a:prstGeom>
           <a:solidFill>
-            <a:srgbClr val="F1F5F9"/>
+            <a:srgbClr val="F8FAFC"/>
           </a:solidFill>
           <a:ln>
             <a:noFill/>
@@ -14994,7 +14994,7 @@
             <a:avLst/>
           </a:prstGeom>
           <a:solidFill>
-            <a:srgbClr val="F1F5F9"/>
+            <a:srgbClr val="F8FAFC"/>
           </a:solidFill>
           <a:ln>
             <a:noFill/>
@@ -15192,7 +15192,7 @@
             <a:avLst/>
           </a:prstGeom>
           <a:solidFill>
-            <a:srgbClr val="F1F5F9"/>
+            <a:srgbClr val="F8FAFC"/>
           </a:solidFill>
           <a:ln>
             <a:noFill/>
@@ -15942,7 +15942,7 @@
         <p:spPr>
           <a:xfrm>
             <a:off x="731520" y="4937760"/>
-            <a:ext cx="10058400" cy="1828800"/>
+            <a:ext cx="10515600" cy="1828800"/>
           </a:xfrm>
           <a:prstGeom prst="rect">
             <a:avLst/>
@@ -15964,7 +15964,7 @@
               </a:defRPr>
             </a:pPr>
             <a:r>
-              <a:t>SaaS Subscription: Per-ED-per-month licensing ($2,000-8,000/mo based on volume)</a:t>
+              <a:t>SaaS Subscription: Per-ED-per-month licensing ($2,000-8,000/mo based on patient volume)</a:t>
             </a:r>
           </a:p>
           <a:p>
@@ -15980,7 +15980,7 @@
               </a:defRPr>
             </a:pPr>
             <a:r>
-              <a:t>Enterprise License: Hospital chain / government health system annual contracts</a:t>
+              <a:t>Enterprise License: Hospital chain / government health network annual contracts</a:t>
             </a:r>
           </a:p>
           <a:p>
@@ -15996,7 +15996,7 @@
               </a:defRPr>
             </a:pPr>
             <a:r>
-              <a:t>API-as-a-Service: Third-party EMR/EHR integration via REST API</a:t>
+              <a:t>API-as-a-Service: Third-party EMR/EHR integration via HL7 FHIR and REST API</a:t>
             </a:r>
           </a:p>
           <a:p>
@@ -16012,7 +16012,7 @@
               </a:defRPr>
             </a:pPr>
             <a:r>
-              <a:t>Training &amp; Certification: Clinician AI-literacy certification programs</a:t>
+              <a:t>Training &amp; Certification: Clinician AI-literacy and triage quality assurance programs</a:t>
             </a:r>
           </a:p>
         </p:txBody>

</xml_diff>